<commit_message>
Updates to conceptual model docs
Fixed powerpoints, diagrams, and word doc.

Change-Id: I77832d850b49eaa6d74b1e1df8465be2fdf8a36e
</commit_message>
<xml_diff>
--- a/HelpResourcesSources/TechnicalNotes/FLEx 9.1 Conceptual Model - Grammar and interlinear model.pptx
+++ b/HelpResourcesSources/TechnicalNotes/FLEx 9.1 Conceptual Model - Grammar and interlinear model.pptx
@@ -320,7 +320,7 @@
           <a:p>
             <a:fld id="{33088F3C-9E81-4E49-8427-25161F1C0BC9}" type="datetimeFigureOut">
               <a:rPr lang="en-US" smtClean="0"/>
-              <a:t>6/21/2024</a:t>
+              <a:t>6/25/2024</a:t>
             </a:fld>
             <a:endParaRPr lang="en-US" dirty="0"/>
           </a:p>
@@ -518,7 +518,7 @@
           <a:p>
             <a:fld id="{33088F3C-9E81-4E49-8427-25161F1C0BC9}" type="datetimeFigureOut">
               <a:rPr lang="en-US" smtClean="0"/>
-              <a:t>6/21/2024</a:t>
+              <a:t>6/25/2024</a:t>
             </a:fld>
             <a:endParaRPr lang="en-US" dirty="0"/>
           </a:p>
@@ -726,7 +726,7 @@
           <a:p>
             <a:fld id="{33088F3C-9E81-4E49-8427-25161F1C0BC9}" type="datetimeFigureOut">
               <a:rPr lang="en-US" smtClean="0"/>
-              <a:t>6/21/2024</a:t>
+              <a:t>6/25/2024</a:t>
             </a:fld>
             <a:endParaRPr lang="en-US" dirty="0"/>
           </a:p>
@@ -924,7 +924,7 @@
           <a:p>
             <a:fld id="{33088F3C-9E81-4E49-8427-25161F1C0BC9}" type="datetimeFigureOut">
               <a:rPr lang="en-US" smtClean="0"/>
-              <a:t>6/21/2024</a:t>
+              <a:t>6/25/2024</a:t>
             </a:fld>
             <a:endParaRPr lang="en-US" dirty="0"/>
           </a:p>
@@ -1199,7 +1199,7 @@
           <a:p>
             <a:fld id="{33088F3C-9E81-4E49-8427-25161F1C0BC9}" type="datetimeFigureOut">
               <a:rPr lang="en-US" smtClean="0"/>
-              <a:t>6/21/2024</a:t>
+              <a:t>6/25/2024</a:t>
             </a:fld>
             <a:endParaRPr lang="en-US" dirty="0"/>
           </a:p>
@@ -1464,7 +1464,7 @@
           <a:p>
             <a:fld id="{33088F3C-9E81-4E49-8427-25161F1C0BC9}" type="datetimeFigureOut">
               <a:rPr lang="en-US" smtClean="0"/>
-              <a:t>6/21/2024</a:t>
+              <a:t>6/25/2024</a:t>
             </a:fld>
             <a:endParaRPr lang="en-US" dirty="0"/>
           </a:p>
@@ -1876,7 +1876,7 @@
           <a:p>
             <a:fld id="{33088F3C-9E81-4E49-8427-25161F1C0BC9}" type="datetimeFigureOut">
               <a:rPr lang="en-US" smtClean="0"/>
-              <a:t>6/21/2024</a:t>
+              <a:t>6/25/2024</a:t>
             </a:fld>
             <a:endParaRPr lang="en-US" dirty="0"/>
           </a:p>
@@ -2017,7 +2017,7 @@
           <a:p>
             <a:fld id="{33088F3C-9E81-4E49-8427-25161F1C0BC9}" type="datetimeFigureOut">
               <a:rPr lang="en-US" smtClean="0"/>
-              <a:t>6/21/2024</a:t>
+              <a:t>6/25/2024</a:t>
             </a:fld>
             <a:endParaRPr lang="en-US" dirty="0"/>
           </a:p>
@@ -2130,7 +2130,7 @@
           <a:p>
             <a:fld id="{33088F3C-9E81-4E49-8427-25161F1C0BC9}" type="datetimeFigureOut">
               <a:rPr lang="en-US" smtClean="0"/>
-              <a:t>6/21/2024</a:t>
+              <a:t>6/25/2024</a:t>
             </a:fld>
             <a:endParaRPr lang="en-US" dirty="0"/>
           </a:p>
@@ -2441,7 +2441,7 @@
           <a:p>
             <a:fld id="{33088F3C-9E81-4E49-8427-25161F1C0BC9}" type="datetimeFigureOut">
               <a:rPr lang="en-US" smtClean="0"/>
-              <a:t>6/21/2024</a:t>
+              <a:t>6/25/2024</a:t>
             </a:fld>
             <a:endParaRPr lang="en-US" dirty="0"/>
           </a:p>
@@ -2729,7 +2729,7 @@
           <a:p>
             <a:fld id="{33088F3C-9E81-4E49-8427-25161F1C0BC9}" type="datetimeFigureOut">
               <a:rPr lang="en-US" smtClean="0"/>
-              <a:t>6/21/2024</a:t>
+              <a:t>6/25/2024</a:t>
             </a:fld>
             <a:endParaRPr lang="en-US" dirty="0"/>
           </a:p>
@@ -2970,7 +2970,7 @@
           <a:p>
             <a:fld id="{33088F3C-9E81-4E49-8427-25161F1C0BC9}" type="datetimeFigureOut">
               <a:rPr lang="en-US" smtClean="0"/>
-              <a:t>6/21/2024</a:t>
+              <a:t>6/25/2024</a:t>
             </a:fld>
             <a:endParaRPr lang="en-US" dirty="0"/>
           </a:p>
@@ -3445,7 +3445,9 @@
           <a:lstStyle/>
           <a:p>
             <a:r>
-              <a:rPr lang="en-US" dirty="0"/>
+              <a:rPr lang="en-US" b="1" dirty="0">
+                <a:latin typeface="+mn-lt"/>
+              </a:rPr>
               <a:t>FLEx 9.1 Conceptual Model</a:t>
             </a:r>
           </a:p>
@@ -3478,7 +3480,7 @@
           <a:lstStyle/>
           <a:p>
             <a:r>
-              <a:rPr lang="en-US" sz="4800" dirty="0"/>
+              <a:rPr lang="en-US" sz="4800" b="1" dirty="0"/>
               <a:t>Grammar and Interlinear model</a:t>
             </a:r>
             <a:br>
@@ -11768,10 +11770,10 @@
       </p:sp>
       <p:pic>
         <p:nvPicPr>
-          <p:cNvPr id="2" name="Picture 1">
-            <a:extLst>
-              <a:ext uri="{FF2B5EF4-FFF2-40B4-BE49-F238E27FC236}">
-                <a16:creationId xmlns:a16="http://schemas.microsoft.com/office/drawing/2014/main" id="{9757E38B-A6CA-424D-B25D-680C283694C5}"/>
+          <p:cNvPr id="3" name="Picture 2">
+            <a:extLst>
+              <a:ext uri="{FF2B5EF4-FFF2-40B4-BE49-F238E27FC236}">
+                <a16:creationId xmlns:a16="http://schemas.microsoft.com/office/drawing/2014/main" id="{3600359A-AA95-4C10-953F-4082AE63ADD2}"/>
               </a:ext>
             </a:extLst>
           </p:cNvPr>
@@ -11788,8 +11790,8 @@
         </p:blipFill>
         <p:spPr>
           <a:xfrm>
-            <a:off x="3325893" y="3780366"/>
-            <a:ext cx="7262025" cy="2718405"/>
+            <a:off x="3550804" y="3860800"/>
+            <a:ext cx="6922511" cy="2512690"/>
           </a:xfrm>
           <a:prstGeom prst="rect">
             <a:avLst/>
@@ -12138,86 +12140,18 @@
           <a:chExt cx="0" cy="0"/>
         </a:xfrm>
       </p:grpSpPr>
-      <p:sp>
-        <p:nvSpPr>
-          <p:cNvPr id="4" name="Title 1">
-            <a:extLst>
-              <a:ext uri="{FF2B5EF4-FFF2-40B4-BE49-F238E27FC236}">
-                <a16:creationId xmlns:a16="http://schemas.microsoft.com/office/drawing/2014/main" id="{D020DABE-C917-4086-9913-77F3DFBC8176}"/>
-              </a:ext>
-            </a:extLst>
-          </p:cNvPr>
-          <p:cNvSpPr>
-            <a:spLocks noGrp="1"/>
-          </p:cNvSpPr>
-          <p:nvPr>
-            <p:ph type="title"/>
-          </p:nvPr>
-        </p:nvSpPr>
-        <p:spPr>
-          <a:xfrm>
-            <a:off x="838200" y="136525"/>
-            <a:ext cx="10515600" cy="803275"/>
-          </a:xfrm>
-        </p:spPr>
-        <p:txBody>
-          <a:bodyPr>
-            <a:normAutofit/>
-          </a:bodyPr>
-          <a:lstStyle/>
-          <a:p>
-            <a:r>
-              <a:rPr lang="en-US" dirty="0"/>
-              <a:t>Notebook model continued</a:t>
-            </a:r>
-          </a:p>
-        </p:txBody>
-      </p:sp>
-      <p:sp>
-        <p:nvSpPr>
-          <p:cNvPr id="5" name="Content Placeholder 2">
-            <a:extLst>
-              <a:ext uri="{FF2B5EF4-FFF2-40B4-BE49-F238E27FC236}">
-                <a16:creationId xmlns:a16="http://schemas.microsoft.com/office/drawing/2014/main" id="{54980C95-9B20-461C-8447-ECB43E44F22E}"/>
-              </a:ext>
-            </a:extLst>
-          </p:cNvPr>
-          <p:cNvSpPr>
-            <a:spLocks noGrp="1"/>
-          </p:cNvSpPr>
-          <p:nvPr>
-            <p:ph idx="1"/>
-          </p:nvPr>
-        </p:nvSpPr>
-        <p:spPr>
-          <a:xfrm>
-            <a:off x="838200" y="939800"/>
-            <a:ext cx="10515600" cy="5681133"/>
-          </a:xfrm>
-        </p:spPr>
-        <p:txBody>
-          <a:bodyPr>
-            <a:normAutofit/>
-          </a:bodyPr>
-          <a:lstStyle/>
-          <a:p>
-            <a:r>
-              <a:rPr lang="en-US" dirty="0"/>
-              <a:t>This is represented in FLEx as</a:t>
-            </a:r>
-          </a:p>
-        </p:txBody>
-      </p:sp>
       <p:pic>
         <p:nvPicPr>
-          <p:cNvPr id="8" name="Picture 7">
-            <a:extLst>
-              <a:ext uri="{FF2B5EF4-FFF2-40B4-BE49-F238E27FC236}">
-                <a16:creationId xmlns:a16="http://schemas.microsoft.com/office/drawing/2014/main" id="{C9FB2C51-88C4-4075-864B-59406CC7809C}"/>
-              </a:ext>
-            </a:extLst>
-          </p:cNvPr>
-          <p:cNvPicPr/>
+          <p:cNvPr id="12" name="Picture 11">
+            <a:extLst>
+              <a:ext uri="{FF2B5EF4-FFF2-40B4-BE49-F238E27FC236}">
+                <a16:creationId xmlns:a16="http://schemas.microsoft.com/office/drawing/2014/main" id="{7ABC3E0C-E10B-44F5-AC2B-F1654C5CCD0C}"/>
+              </a:ext>
+            </a:extLst>
+          </p:cNvPr>
+          <p:cNvPicPr>
+            <a:picLocks noChangeAspect="1"/>
+          </p:cNvPicPr>
           <p:nvPr/>
         </p:nvPicPr>
         <p:blipFill>
@@ -12228,14 +12162,84 @@
         </p:blipFill>
         <p:spPr>
           <a:xfrm>
-            <a:off x="292902" y="1864675"/>
-            <a:ext cx="7356082" cy="3682934"/>
+            <a:off x="152275" y="1841418"/>
+            <a:ext cx="7366198" cy="3660613"/>
           </a:xfrm>
           <a:prstGeom prst="rect">
             <a:avLst/>
           </a:prstGeom>
         </p:spPr>
       </p:pic>
+      <p:sp>
+        <p:nvSpPr>
+          <p:cNvPr id="4" name="Title 1">
+            <a:extLst>
+              <a:ext uri="{FF2B5EF4-FFF2-40B4-BE49-F238E27FC236}">
+                <a16:creationId xmlns:a16="http://schemas.microsoft.com/office/drawing/2014/main" id="{D020DABE-C917-4086-9913-77F3DFBC8176}"/>
+              </a:ext>
+            </a:extLst>
+          </p:cNvPr>
+          <p:cNvSpPr>
+            <a:spLocks noGrp="1"/>
+          </p:cNvSpPr>
+          <p:nvPr>
+            <p:ph type="title"/>
+          </p:nvPr>
+        </p:nvSpPr>
+        <p:spPr>
+          <a:xfrm>
+            <a:off x="838200" y="136525"/>
+            <a:ext cx="10515600" cy="803275"/>
+          </a:xfrm>
+        </p:spPr>
+        <p:txBody>
+          <a:bodyPr>
+            <a:normAutofit/>
+          </a:bodyPr>
+          <a:lstStyle/>
+          <a:p>
+            <a:r>
+              <a:rPr lang="en-US" dirty="0"/>
+              <a:t>Notebook model continued</a:t>
+            </a:r>
+          </a:p>
+        </p:txBody>
+      </p:sp>
+      <p:sp>
+        <p:nvSpPr>
+          <p:cNvPr id="5" name="Content Placeholder 2">
+            <a:extLst>
+              <a:ext uri="{FF2B5EF4-FFF2-40B4-BE49-F238E27FC236}">
+                <a16:creationId xmlns:a16="http://schemas.microsoft.com/office/drawing/2014/main" id="{54980C95-9B20-461C-8447-ECB43E44F22E}"/>
+              </a:ext>
+            </a:extLst>
+          </p:cNvPr>
+          <p:cNvSpPr>
+            <a:spLocks noGrp="1"/>
+          </p:cNvSpPr>
+          <p:nvPr>
+            <p:ph idx="1"/>
+          </p:nvPr>
+        </p:nvSpPr>
+        <p:spPr>
+          <a:xfrm>
+            <a:off x="838200" y="939800"/>
+            <a:ext cx="10515600" cy="5681133"/>
+          </a:xfrm>
+        </p:spPr>
+        <p:txBody>
+          <a:bodyPr>
+            <a:normAutofit/>
+          </a:bodyPr>
+          <a:lstStyle/>
+          <a:p>
+            <a:r>
+              <a:rPr lang="en-US" dirty="0"/>
+              <a:t>This is represented in FLEx as</a:t>
+            </a:r>
+          </a:p>
+        </p:txBody>
+      </p:sp>
       <p:sp>
         <p:nvSpPr>
           <p:cNvPr id="2" name="TextBox 1">
@@ -13101,6 +13105,80 @@
           </a:prstGeom>
         </p:spPr>
       </p:pic>
+      <p:sp>
+        <p:nvSpPr>
+          <p:cNvPr id="6" name="TextBox 5">
+            <a:extLst>
+              <a:ext uri="{FF2B5EF4-FFF2-40B4-BE49-F238E27FC236}">
+                <a16:creationId xmlns:a16="http://schemas.microsoft.com/office/drawing/2014/main" id="{C6F527EE-E5C4-4B0F-9451-A5FCFC192CD1}"/>
+              </a:ext>
+            </a:extLst>
+          </p:cNvPr>
+          <p:cNvSpPr txBox="1"/>
+          <p:nvPr/>
+        </p:nvSpPr>
+        <p:spPr>
+          <a:xfrm>
+            <a:off x="8136488" y="796670"/>
+            <a:ext cx="1978267" cy="400110"/>
+          </a:xfrm>
+          <a:prstGeom prst="rect">
+            <a:avLst/>
+          </a:prstGeom>
+          <a:noFill/>
+        </p:spPr>
+        <p:txBody>
+          <a:bodyPr wrap="square" rtlCol="0">
+            <a:spAutoFit/>
+          </a:bodyPr>
+          <a:lstStyle/>
+          <a:p>
+            <a:r>
+              <a:rPr lang="en-US" sz="2000" b="1" dirty="0" err="1"/>
+              <a:t>mang</a:t>
+            </a:r>
+            <a:r>
+              <a:rPr lang="en-US" sz="2000" b="1" dirty="0"/>
+              <a:t> / manger</a:t>
+            </a:r>
+          </a:p>
+        </p:txBody>
+      </p:sp>
+      <p:sp>
+        <p:nvSpPr>
+          <p:cNvPr id="7" name="TextBox 6">
+            <a:extLst>
+              <a:ext uri="{FF2B5EF4-FFF2-40B4-BE49-F238E27FC236}">
+                <a16:creationId xmlns:a16="http://schemas.microsoft.com/office/drawing/2014/main" id="{963664E0-2F07-4D07-B241-58BA0FAAF3BA}"/>
+              </a:ext>
+            </a:extLst>
+          </p:cNvPr>
+          <p:cNvSpPr txBox="1"/>
+          <p:nvPr/>
+        </p:nvSpPr>
+        <p:spPr>
+          <a:xfrm>
+            <a:off x="9616943" y="2376221"/>
+            <a:ext cx="441455" cy="400110"/>
+          </a:xfrm>
+          <a:prstGeom prst="rect">
+            <a:avLst/>
+          </a:prstGeom>
+          <a:noFill/>
+        </p:spPr>
+        <p:txBody>
+          <a:bodyPr wrap="square" rtlCol="0">
+            <a:spAutoFit/>
+          </a:bodyPr>
+          <a:lstStyle/>
+          <a:p>
+            <a:r>
+              <a:rPr lang="en-US" sz="2000" b="1" dirty="0"/>
+              <a:t>-e</a:t>
+            </a:r>
+          </a:p>
+        </p:txBody>
+      </p:sp>
     </p:spTree>
     <p:extLst>
       <p:ext uri="{BB962C8B-B14F-4D97-AF65-F5344CB8AC3E}">
@@ -13239,15 +13317,7 @@
             </a:r>
             <a:r>
               <a:rPr lang="en-US" dirty="0"/>
-              <a:t> connection to </a:t>
-            </a:r>
-            <a:r>
-              <a:rPr lang="en-US" dirty="0" err="1"/>
-              <a:t>varios</a:t>
-            </a:r>
-            <a:r>
-              <a:rPr lang="en-US" dirty="0"/>
-              <a:t> parts of the feature system</a:t>
+              <a:t> connection to various parts of the feature system</a:t>
             </a:r>
           </a:p>
         </p:txBody>
@@ -13274,6 +13344,36 @@
           <a:xfrm>
             <a:off x="6457722" y="46943"/>
             <a:ext cx="5331507" cy="6791132"/>
+          </a:xfrm>
+          <a:prstGeom prst="rect">
+            <a:avLst/>
+          </a:prstGeom>
+        </p:spPr>
+      </p:pic>
+      <p:pic>
+        <p:nvPicPr>
+          <p:cNvPr id="2" name="Picture 1">
+            <a:extLst>
+              <a:ext uri="{FF2B5EF4-FFF2-40B4-BE49-F238E27FC236}">
+                <a16:creationId xmlns:a16="http://schemas.microsoft.com/office/drawing/2014/main" id="{46F15017-E279-4422-BBF5-37FF010633BD}"/>
+              </a:ext>
+            </a:extLst>
+          </p:cNvPr>
+          <p:cNvPicPr>
+            <a:picLocks noChangeAspect="1"/>
+          </p:cNvPicPr>
+          <p:nvPr/>
+        </p:nvPicPr>
+        <p:blipFill>
+          <a:blip r:embed="rId3"/>
+          <a:stretch>
+            <a:fillRect/>
+          </a:stretch>
+        </p:blipFill>
+        <p:spPr>
+          <a:xfrm>
+            <a:off x="1259382" y="4493845"/>
+            <a:ext cx="4171596" cy="1813413"/>
           </a:xfrm>
           <a:prstGeom prst="rect">
             <a:avLst/>
@@ -13419,7 +13519,7 @@
             </a:br>
             <a:r>
               <a:rPr lang="en-US" dirty="0"/>
-              <a:t>Word Analyses.</a:t>
+              <a:t>Word Analyses and Interlinear Texts.</a:t>
             </a:r>
           </a:p>
           <a:p>

</xml_diff>

<commit_message>
Conceptual model file update
Fixed some typos in files.

Change-Id: Id78e1dd489b3aca0a9574e341a1665c2bcaf837e
</commit_message>
<xml_diff>
--- a/HelpResourcesSources/TechnicalNotes/FLEx 9.1 Conceptual Model - Grammar and interlinear model.pptx
+++ b/HelpResourcesSources/TechnicalNotes/FLEx 9.1 Conceptual Model - Grammar and interlinear model.pptx
@@ -320,7 +320,7 @@
           <a:p>
             <a:fld id="{33088F3C-9E81-4E49-8427-25161F1C0BC9}" type="datetimeFigureOut">
               <a:rPr lang="en-US" smtClean="0"/>
-              <a:t>6/25/2024</a:t>
+              <a:t>7/9/2024</a:t>
             </a:fld>
             <a:endParaRPr lang="en-US" dirty="0"/>
           </a:p>
@@ -518,7 +518,7 @@
           <a:p>
             <a:fld id="{33088F3C-9E81-4E49-8427-25161F1C0BC9}" type="datetimeFigureOut">
               <a:rPr lang="en-US" smtClean="0"/>
-              <a:t>6/25/2024</a:t>
+              <a:t>7/9/2024</a:t>
             </a:fld>
             <a:endParaRPr lang="en-US" dirty="0"/>
           </a:p>
@@ -726,7 +726,7 @@
           <a:p>
             <a:fld id="{33088F3C-9E81-4E49-8427-25161F1C0BC9}" type="datetimeFigureOut">
               <a:rPr lang="en-US" smtClean="0"/>
-              <a:t>6/25/2024</a:t>
+              <a:t>7/9/2024</a:t>
             </a:fld>
             <a:endParaRPr lang="en-US" dirty="0"/>
           </a:p>
@@ -924,7 +924,7 @@
           <a:p>
             <a:fld id="{33088F3C-9E81-4E49-8427-25161F1C0BC9}" type="datetimeFigureOut">
               <a:rPr lang="en-US" smtClean="0"/>
-              <a:t>6/25/2024</a:t>
+              <a:t>7/9/2024</a:t>
             </a:fld>
             <a:endParaRPr lang="en-US" dirty="0"/>
           </a:p>
@@ -1199,7 +1199,7 @@
           <a:p>
             <a:fld id="{33088F3C-9E81-4E49-8427-25161F1C0BC9}" type="datetimeFigureOut">
               <a:rPr lang="en-US" smtClean="0"/>
-              <a:t>6/25/2024</a:t>
+              <a:t>7/9/2024</a:t>
             </a:fld>
             <a:endParaRPr lang="en-US" dirty="0"/>
           </a:p>
@@ -1464,7 +1464,7 @@
           <a:p>
             <a:fld id="{33088F3C-9E81-4E49-8427-25161F1C0BC9}" type="datetimeFigureOut">
               <a:rPr lang="en-US" smtClean="0"/>
-              <a:t>6/25/2024</a:t>
+              <a:t>7/9/2024</a:t>
             </a:fld>
             <a:endParaRPr lang="en-US" dirty="0"/>
           </a:p>
@@ -1876,7 +1876,7 @@
           <a:p>
             <a:fld id="{33088F3C-9E81-4E49-8427-25161F1C0BC9}" type="datetimeFigureOut">
               <a:rPr lang="en-US" smtClean="0"/>
-              <a:t>6/25/2024</a:t>
+              <a:t>7/9/2024</a:t>
             </a:fld>
             <a:endParaRPr lang="en-US" dirty="0"/>
           </a:p>
@@ -2017,7 +2017,7 @@
           <a:p>
             <a:fld id="{33088F3C-9E81-4E49-8427-25161F1C0BC9}" type="datetimeFigureOut">
               <a:rPr lang="en-US" smtClean="0"/>
-              <a:t>6/25/2024</a:t>
+              <a:t>7/9/2024</a:t>
             </a:fld>
             <a:endParaRPr lang="en-US" dirty="0"/>
           </a:p>
@@ -2130,7 +2130,7 @@
           <a:p>
             <a:fld id="{33088F3C-9E81-4E49-8427-25161F1C0BC9}" type="datetimeFigureOut">
               <a:rPr lang="en-US" smtClean="0"/>
-              <a:t>6/25/2024</a:t>
+              <a:t>7/9/2024</a:t>
             </a:fld>
             <a:endParaRPr lang="en-US" dirty="0"/>
           </a:p>
@@ -2441,7 +2441,7 @@
           <a:p>
             <a:fld id="{33088F3C-9E81-4E49-8427-25161F1C0BC9}" type="datetimeFigureOut">
               <a:rPr lang="en-US" smtClean="0"/>
-              <a:t>6/25/2024</a:t>
+              <a:t>7/9/2024</a:t>
             </a:fld>
             <a:endParaRPr lang="en-US" dirty="0"/>
           </a:p>
@@ -2729,7 +2729,7 @@
           <a:p>
             <a:fld id="{33088F3C-9E81-4E49-8427-25161F1C0BC9}" type="datetimeFigureOut">
               <a:rPr lang="en-US" smtClean="0"/>
-              <a:t>6/25/2024</a:t>
+              <a:t>7/9/2024</a:t>
             </a:fld>
             <a:endParaRPr lang="en-US" dirty="0"/>
           </a:p>
@@ -2970,7 +2970,7 @@
           <a:p>
             <a:fld id="{33088F3C-9E81-4E49-8427-25161F1C0BC9}" type="datetimeFigureOut">
               <a:rPr lang="en-US" smtClean="0"/>
-              <a:t>6/25/2024</a:t>
+              <a:t>7/9/2024</a:t>
             </a:fld>
             <a:endParaRPr lang="en-US" dirty="0"/>
           </a:p>
@@ -8903,7 +8903,7 @@
             <a:pPr lvl="1"/>
             <a:r>
               <a:rPr lang="en-US" dirty="0"/>
-              <a:t>The “Text Markup Tags” list is owned in the </a:t>
+              <a:t>The “Text Chart Markers” list is owned in the </a:t>
             </a:r>
             <a:r>
               <a:rPr lang="en-US" dirty="0" err="1"/>
@@ -9764,7 +9764,7 @@
             </a:r>
             <a:r>
               <a:rPr lang="en-US" dirty="0" err="1"/>
-              <a:t>TesnseAspectMood</a:t>
+              <a:t>TenseAspectMood</a:t>
             </a:r>
             <a:r>
               <a:rPr lang="en-US" dirty="0"/>
@@ -11521,7 +11521,7 @@
             </a:r>
             <a:r>
               <a:rPr lang="en-US" dirty="0"/>
-              <a:t> – an Integer representing the book, chapter, and verse that starts this section in the form BBCCCCVVVV.</a:t>
+              <a:t> – an Integer representing the book, chapter, and verse that starts this section in the form BBCCCVVV.</a:t>
             </a:r>
           </a:p>
           <a:p>
@@ -11532,7 +11532,7 @@
             </a:r>
             <a:r>
               <a:rPr lang="en-US" dirty="0"/>
-              <a:t> – an Integer representing the book, chapter, and verse that ends this section in the form BBCCCCVVVV.</a:t>
+              <a:t> – an Integer representing the book, chapter, and verse that ends this section in the form BBCCCVVV.</a:t>
             </a:r>
           </a:p>
           <a:p>
@@ -12142,10 +12142,10 @@
       </p:grpSpPr>
       <p:pic>
         <p:nvPicPr>
-          <p:cNvPr id="12" name="Picture 11">
-            <a:extLst>
-              <a:ext uri="{FF2B5EF4-FFF2-40B4-BE49-F238E27FC236}">
-                <a16:creationId xmlns:a16="http://schemas.microsoft.com/office/drawing/2014/main" id="{7ABC3E0C-E10B-44F5-AC2B-F1654C5CCD0C}"/>
+          <p:cNvPr id="8" name="Picture 7">
+            <a:extLst>
+              <a:ext uri="{FF2B5EF4-FFF2-40B4-BE49-F238E27FC236}">
+                <a16:creationId xmlns:a16="http://schemas.microsoft.com/office/drawing/2014/main" id="{7F48A357-A5C9-4A45-B37C-E94EEF6CC4FB}"/>
               </a:ext>
             </a:extLst>
           </p:cNvPr>
@@ -12162,8 +12162,8 @@
         </p:blipFill>
         <p:spPr>
           <a:xfrm>
-            <a:off x="152275" y="1841418"/>
-            <a:ext cx="7366198" cy="3660613"/>
+            <a:off x="352842" y="1841344"/>
+            <a:ext cx="7360819" cy="3666828"/>
           </a:xfrm>
           <a:prstGeom prst="rect">
             <a:avLst/>

</xml_diff>